<commit_message>
fix(mimo): rectify analytical derivations, numerical accuracy, and report coherence
- Correct SNR requirements and power gain at BER 10^-3 (16.9 dB / ~49x power reduction)
- Accurately compute singular values and eigenvalues for H ([0.7 0.3; 0.4 0.6])
- Update Water-filling threshold to 10.10 dB and clarify SVD noise enhancement vs cross-talk elimination
- Set SDM diversity order to d=1 for linear receivers and adopt Zheng-Tse piecewise DMT
- Clarify QPSK for step recovery and BPSK for Monte Carlo BER simulations
- Transparently document terminal simulation outputs and epsilon machine errors
- Align project instruction scope with P1/P2 foundations, add citations [1]-[10], remove hard-coded paths, add verification asserts
- Regenerate report PDF (43 pages), presentation PPTX/PDF, and slide previews
</commit_message>
<xml_diff>
--- a/slides/Slide_ThuyetTrinh_MIMO_2026.pptx
+++ b/slides/Slide_ThuyetTrinh_MIMO_2026.pptx
@@ -3929,7 +3929,7 @@
             </a:r>
             <a:br/>
             <a:r>
-              <a:t>  Σ = diag(σ_1, σ_2) = diag(1.00596, 0.29671)</a:t>
+              <a:t>  Σ = diag(σ_1, σ_2) = diag(1.0055, 0.2984), κ(H) = 3.37</a:t>
             </a:r>
           </a:p>
           <a:p>
@@ -3981,15 +3981,15 @@
               </a:defRPr>
             </a:pPr>
             <a:r>
-              <a:t>•  Hai kênh con trực giao song song hoàn toàn độc lập:</a:t>
+              <a:t>•  Hai kênh con trực giao song song không can nhiễu luồng:</a:t>
             </a:r>
             <a:br/>
             <a:r>
-              <a:t>  y_tilde_1 = 1.00596 x1 + n_tilde_1</a:t>
+              <a:t>  y_tilde_1 = 1.0055 x1 + n_tilde_1</a:t>
             </a:r>
             <a:br/>
             <a:r>
-              <a:t>  y_tilde_2 = 0.29671 x2 + n_tilde_2</a:t>
+              <a:t>  y_tilde_2 = 0.2984 x2 + n_tilde_2</a:t>
             </a:r>
           </a:p>
           <a:p>
@@ -4005,15 +4005,15 @@
               </a:defRPr>
             </a:pPr>
             <a:r>
-              <a:t>•  Bảo toàn phân bố tạp âm:</a:t>
+              <a:t>•  Đặc tính tạp âm &amp; Khôi phục:</a:t>
             </a:r>
             <a:br/>
             <a:r>
-              <a:t>  Do U là ma trận unita nên R_n_tilde = σ_n^2 U^H U = σ_n^2 I_2.</a:t>
+              <a:t>  Do U là ma trận unita nên R_n_tilde = σ_n^2 U^H U = σ_n^2 I_2 (giữ trắng tạp âm).</a:t>
             </a:r>
             <a:br/>
             <a:r>
-              <a:t>  =&gt; Hoàn toàn không bị khuếch đại tạp âm!</a:t>
+              <a:t>  Khi tách ký hiệu x_hat_i = y_tilde_i / σ_i, phương sai nhiễu luồng 2 tăng 1/σ_2^2 ≈ 11.23 lần. SVD loại bỏ hoàn toàn can nhiễu chéo, cho phép Water-filling tối ưu hóa.</a:t>
             </a:r>
           </a:p>
           <a:p>
@@ -4337,7 +4337,7 @@
               </a:defRPr>
             </a:pPr>
             <a:r>
-              <a:t>Ảnh chụp Kết quả Chạy Mô phỏng Thực tế trên Terminal MATLAB</a:t>
+              <a:t>Kết quả Mô phỏng Số Khôi phục Tín hiệu Thực thi trên MATLAB</a:t>
             </a:r>
           </a:p>
         </p:txBody>
@@ -4536,7 +4536,7 @@
         <p:spPr>
           <a:xfrm>
             <a:off x="1188720" y="1920240"/>
-            <a:ext cx="3714579" cy="3474720"/>
+            <a:ext cx="3280239" cy="3474720"/>
           </a:xfrm>
           <a:prstGeom prst="rect">
             <a:avLst/>
@@ -4574,7 +4574,7 @@
               </a:defRPr>
             </a:pPr>
             <a:r>
-              <a:t>Xác thực mô phỏng STBC: Tính toán 4 giá trị r0..r3, H_eff trực giao, khôi phục x0, x1 với sai số 1.11e-16.</a:t>
+              <a:t>Mô phỏng STBC: Tính toán 4 giá trị r0..r3, H_eff trực giao, khôi phục x0, x1 với sai số máy tính 2.22e-16 (MATLAB) / 1.11e-16 (Python).</a:t>
             </a:r>
           </a:p>
         </p:txBody>
@@ -4694,7 +4694,7 @@
         <p:spPr>
           <a:xfrm>
             <a:off x="7589520" y="1874519"/>
-            <a:ext cx="1927150" cy="3566160"/>
+            <a:ext cx="1715282" cy="3566160"/>
           </a:xfrm>
           <a:prstGeom prst="rect">
             <a:avLst/>
@@ -4732,7 +4732,7 @@
               </a:defRPr>
             </a:pPr>
             <a:r>
-              <a:t>Xác thực mô phỏng SDM: Nghịch đảo ZF, hệ số khuếch đại nhiễu 5.0x và 7.2x, kiểm chứng MMSE và SVD.</a:t>
+              <a:t>Mô phỏng SDM: Nghịch đảo ZF, hệ số khuếch đại nhiễu 5.0x và 7.22x, kiểm chứng MMSE và SVD (sai số &lt; 1.05e-15).</a:t>
             </a:r>
           </a:p>
         </p:txBody>
@@ -6060,7 +6060,7 @@
             </a:r>
             <a:br/>
             <a:r>
-              <a:t>Các điểm mô phỏng 2x10^5 bit (markers) trùng khớp tuyệt đối với các đường cong lý thuyết giải tích liên tục trên toàn dải SNR từ 0 đến 25 dB.</a:t>
+              <a:t>Các điểm mô phỏng 5x10^5 bit (markers) khớp tốt với các đường cong lý thuyết giải tích liên tục trên toàn dải SNR từ 0 đến 25 dB.</a:t>
             </a:r>
           </a:p>
           <a:p>
@@ -6120,7 +6120,7 @@
             </a:r>
             <a:br/>
             <a:r>
-              <a:t>  =&gt; MIMO 2x2 giảm lỗi hơn 218 lần so với SISO!</a:t>
+              <a:t>  =&gt; MIMO 2x2 giảm lỗi 218 lần trong mô phỏng (lý thuyết giải tích: 205 lần) so với SISO!</a:t>
             </a:r>
           </a:p>
           <a:p>
@@ -6657,7 +6657,7 @@
                         </a:defRPr>
                       </a:pPr>
                       <a:r>
-                        <a:t>23.9 dB</a:t>
+                        <a:t>24.0 dB</a:t>
                       </a:r>
                     </a:p>
                   </a:txBody>
@@ -6755,7 +6755,7 @@
                         </a:defRPr>
                       </a:pPr>
                       <a:r>
-                        <a:t>14.0 dB</a:t>
+                        <a:t>14.1 dB</a:t>
                       </a:r>
                     </a:p>
                   </a:txBody>
@@ -6853,7 +6853,7 @@
                         </a:defRPr>
                       </a:pPr>
                       <a:r>
-                        <a:t>13.5 dB</a:t>
+                        <a:t>12.6 dB</a:t>
                       </a:r>
                     </a:p>
                   </a:txBody>
@@ -6877,7 +6877,7 @@
                         </a:defRPr>
                       </a:pPr>
                       <a:r>
-                        <a:t>+10.4 dB</a:t>
+                        <a:t>+11.4 dB</a:t>
                       </a:r>
                     </a:p>
                   </a:txBody>
@@ -6951,7 +6951,7 @@
                         </a:defRPr>
                       </a:pPr>
                       <a:r>
-                        <a:t>11.0 dB</a:t>
+                        <a:t>11.1 dB</a:t>
                       </a:r>
                     </a:p>
                   </a:txBody>
@@ -7049,7 +7049,7 @@
                         </a:defRPr>
                       </a:pPr>
                       <a:r>
-                        <a:t>7.4 dB</a:t>
+                        <a:t>7.05 dB</a:t>
                       </a:r>
                     </a:p>
                   </a:txBody>
@@ -7073,7 +7073,7 @@
                         </a:defRPr>
                       </a:pPr>
                       <a:r>
-                        <a:t>+16.5 dB (Vượt trội)</a:t>
+                        <a:t>+16.9 dB (Vượt trội)</a:t>
                       </a:r>
                     </a:p>
                   </a:txBody>
@@ -7122,7 +7122,7 @@
               </a:defRPr>
             </a:pPr>
             <a:r>
-              <a:t>•  Độ lợi công suất vượt bậc: MIMO 2x2 STBC chỉ cần 7.4 dB để đạt BER = 10^-3, tiết kiệm tới 16.5 dB so với SISO (23.9 dB).</a:t>
+              <a:t>•  Độ lợi công suất vượt bậc: MIMO 2x2 STBC chỉ cần 7.05 dB để đạt BER = 10^-3, tiết kiệm tới 16.9 dB so với SISO (24.0 dB).</a:t>
             </a:r>
           </a:p>
           <a:p>
@@ -7138,7 +7138,7 @@
               </a:defRPr>
             </a:pPr>
             <a:r>
-              <a:t>•  Ý nghĩa thực tiễn: Giảm công suất phát của máy phát đi xấp xỉ 45 lần mà vẫn duy trì chất lượng đường truyền tương đương.</a:t>
+              <a:t>•  Ý nghĩa thực tiễn: Giảm công suất phát của máy phát đi xấp xỉ 49 lần mà vẫn duy trì chất lượng đường truyền tương đương.</a:t>
             </a:r>
           </a:p>
         </p:txBody>
@@ -7319,7 +7319,7 @@
             </a:r>
             <a:br/>
             <a:r>
-              <a:t>Tiết kiệm 16.5 dB công suất đồng nghĩa với việc gia tăng thời lượng sử dụng pin của thiết bị di động, kéo dài tầm phủ sóng của trạm gốc, và giảm phát thải can nhiễu vào môi trường vô tuyến.</a:t>
+              <a:t>Tiết kiệm 16.9 dB công suất (xấp xỉ 49 lần) đồng nghĩa với việc gia tăng thời lượng sử dụng pin của thiết bị di động, kéo dài tầm phủ sóng của trạm gốc, và giảm phát thải can nhiễu vào môi trường vô tuyến.</a:t>
             </a:r>
           </a:p>
         </p:txBody>
@@ -8422,11 +8422,11 @@
             </a:r>
             <a:br/>
             <a:r>
-              <a:t>  Δ = 1/σ_2^2 - 1/σ_1^2 = 11.358 - 0.988 = 10.370</a:t>
+              <a:t>  Δ = 1/σ_2^2 - 1/σ_1^2 = 11.233 - 0.989 = 10.244</a:t>
             </a:r>
             <a:br/>
             <a:r>
-              <a:t>  =&gt; Tương ứng với ngưỡng SNR_th ≈ 10.15 dB</a:t>
+              <a:t>  =&gt; Tương ứng với ngưỡng SNR_th = 10 log10(10.244) ≈ 10.10 dB</a:t>
             </a:r>
           </a:p>
           <a:p>
@@ -8446,7 +8446,7 @@
             </a:r>
             <a:br/>
             <a:r>
-              <a:t>  • SNR ≤ 10.15 dB: Nước chưa ngập đáy 2 =&gt; p1 = P_t, p2 = 0.</a:t>
+              <a:t>  • SNR ≤ 10.10 dB: Nước chưa ngập đáy 2 =&gt; p1 = P_t, p2 = 0.</a:t>
             </a:r>
             <a:br/>
             <a:r>
@@ -8454,7 +8454,7 @@
             </a:r>
             <a:br/>
             <a:r>
-              <a:t>  • SNR &gt; 10.15 dB: Nước tràn sang đáy 2 =&gt; Cả 2 kênh con đều có công suất. Chuyển sang Ghép kênh đa luồng.</a:t>
+              <a:t>  • SNR &gt; 10.10 dB: Nước tràn sang đáy 2 =&gt; Cả 2 kênh con đều có công suất. Chuyển sang Ghép kênh đa luồng.</a:t>
             </a:r>
           </a:p>
           <a:p>
@@ -8628,7 +8628,7 @@
               </a:defRPr>
             </a:pPr>
             <a:r>
-              <a:t>Hình 4.2: Minh họa phân bổ công suất tối ưu Water-filling trên kênh MIMO 2x2 (Ngưỡng chuyển tiếp chế độ 10.15 dB).</a:t>
+              <a:t>Hình 4.2: Minh họa phân bổ công suất tối ưu Water-filling trên kênh MIMO 2x2 (Ngưỡng chuyển tiếp chế độ 10.10 dB).</a:t>
             </a:r>
           </a:p>
         </p:txBody>
@@ -9913,7 +9913,7 @@
               </a:defRPr>
             </a:pPr>
             <a:r>
-              <a:t>•  Vùng SNR thấp (&lt; 10 dB): EPA bị suy thoái do lãng phí công suất vào kênh con yếu (σ_2=0.297). Water-filling khắc phục triệt để bằng cách dồn lực cho kênh con mạnh.</a:t>
+              <a:t>•  Vùng SNR thấp (&lt; 10 dB): EPA bị suy thoái do lãng phí công suất vào kênh con yếu (σ_2=0.298). Water-filling khắc phục triệt để bằng cách dồn lực cho kênh con mạnh.</a:t>
             </a:r>
           </a:p>
           <a:p>
@@ -9929,7 +9929,7 @@
               </a:defRPr>
             </a:pPr>
             <a:r>
-              <a:t>•  Vùng SNR cao (&gt; 20 dB): MIMO 2x2 bứt phá vượt trội so với SISO (+4.52 bps/Hz tại 20 dB và +7.77 bps/Hz tại 30 dB trên kênh ergodic).</a:t>
+              <a:t>•  Vùng SNR cao (&gt; 20 dB): MIMO 2x2 bứt phá vượt trội so với SISO (+4.65 bps/Hz tại 20 dB và +7.77 bps/Hz tại 30 dB trên kênh ergodic).</a:t>
             </a:r>
           </a:p>
         </p:txBody>
@@ -10285,9 +10285,9 @@
           <a:p>
             <a:pPr>
               <a:spcAft>
-                <a:spcPts val="600"/>
+                <a:spcPts val="500"/>
               </a:spcAft>
-              <a:defRPr sz="1050">
+              <a:defRPr sz="1000">
                 <a:solidFill>
                   <a:srgbClr val="1E293B"/>
                 </a:solidFill>
@@ -10295,19 +10295,27 @@
               </a:defRPr>
             </a:pPr>
             <a:r>
-              <a:t>•  Hệ thức đánh đổi DMT cho hệ thống MIMO 2x2:</a:t>
+              <a:t>•  Hệ thức đánh đổi DMT Zheng - Tse (2003) cho MIMO 2x2:</a:t>
             </a:r>
             <a:br/>
             <a:r>
-              <a:t>  d(r) = (N_t - r)(N_r - r) = (2 - r)^2   với  0 ≤ r ≤ 2</a:t>
+              <a:t>  d*(r) là đường gấp khúc tuyến tính từng đoạn nối 3 điểm (0, 4) -&gt; (1, 1) -&gt; (2, 0):</a:t>
+            </a:r>
+            <a:br/>
+            <a:r>
+              <a:t>  • 0 ≤ r ≤ 1: d*(r) = 4 - 3r</a:t>
+            </a:r>
+            <a:br/>
+            <a:r>
+              <a:t>  • 1 ≤ r ≤ 2: d*(r) = 2 - r</a:t>
             </a:r>
           </a:p>
           <a:p>
             <a:pPr>
               <a:spcAft>
-                <a:spcPts val="600"/>
+                <a:spcPts val="500"/>
               </a:spcAft>
-              <a:defRPr sz="1050">
+              <a:defRPr sz="1000">
                 <a:solidFill>
                   <a:srgbClr val="1E293B"/>
                 </a:solidFill>
@@ -10315,15 +10323,15 @@
               </a:defRPr>
             </a:pPr>
             <a:r>
-              <a:t>•  Bản chất vật lý: Cùng một số lượng anten trong không gian, hệ thống không thể đồng thời tối đa hóa cả độ tin cậy và tốc độ truyền dữ liệu.</a:t>
+              <a:t>•  Bản chất vật lý: Cùng cấu hình anten, không thể đồng thời tối đa hóa cả độ tin cậy và tốc độ ghép kênh.</a:t>
             </a:r>
           </a:p>
           <a:p>
             <a:pPr>
               <a:spcAft>
-                <a:spcPts val="600"/>
+                <a:spcPts val="500"/>
               </a:spcAft>
-              <a:defRPr sz="1050">
+              <a:defRPr sz="1000">
                 <a:solidFill>
                   <a:srgbClr val="1E293B"/>
                 </a:solidFill>
@@ -10331,15 +10339,15 @@
               </a:defRPr>
             </a:pPr>
             <a:r>
-              <a:t>•  Cực biên 1 (r = 0): Đạt bậc phân tập tối đa d_max = 4  ⇒  Kỹ thuật STBC Alamouti (Tối đa tin cậy, chống fading sâu).</a:t>
+              <a:t>•  Cực biên phân tập (r = 0): Đạt bậc phân tập tối đa d_max = 4 ⇒ Kỹ thuật STBC Alamouti (Tối đa tin cậy, chống fading sâu).</a:t>
             </a:r>
           </a:p>
           <a:p>
             <a:pPr>
               <a:spcAft>
-                <a:spcPts val="600"/>
+                <a:spcPts val="500"/>
               </a:spcAft>
-              <a:defRPr sz="1050">
+              <a:defRPr sz="1000">
                 <a:solidFill>
                   <a:srgbClr val="1E293B"/>
                 </a:solidFill>
@@ -10347,7 +10355,23 @@
               </a:defRPr>
             </a:pPr>
             <a:r>
-              <a:t>•  Cực biên 2 (d = 0): Đạt tốc độ ghép kênh tối đa r_max = 2  ⇒  Kỹ thuật SDM (Tối đa thông lượng, nhân đôi tốc độ).</a:t>
+              <a:t>•  Cực biên ghép kênh (r = 2): Đạt tốc độ ghép kênh tối đa r_max = 2 ⇒ Kỹ thuật SDM (Tối đa thông lượng, d = 0 tại r=2).</a:t>
+            </a:r>
+          </a:p>
+          <a:p>
+            <a:pPr>
+              <a:spcAft>
+                <a:spcPts val="500"/>
+              </a:spcAft>
+              <a:defRPr sz="1000">
+                <a:solidFill>
+                  <a:srgbClr val="1E293B"/>
+                </a:solidFill>
+                <a:latin typeface="Arial"/>
+              </a:defRPr>
+            </a:pPr>
+            <a:r>
+              <a:t>•  Phân tập máy thu SDM: Ở tốc độ cố định với bộ tách sóng tuyến tính ZF/MMSE, mỗi luồng đạt bậc phân tập d = N_r - N_t + 1 = 1.</a:t>
             </a:r>
           </a:p>
         </p:txBody>
@@ -10758,7 +10782,7 @@
                         </a:defRPr>
                       </a:pPr>
                       <a:r>
-                        <a:t>d = 0 (với tách sóng ZF)</a:t>
+                        <a:t>d = 1 (ZF/MMSE cố định) / d = 0 (tại r=2)</a:t>
                       </a:r>
                     </a:p>
                   </a:txBody>
@@ -11954,7 +11978,7 @@
                         </a:defRPr>
                       </a:pPr>
                       <a:r>
-                        <a:t>+16.5 dB</a:t>
+                        <a:t>+16.9 dB</a:t>
                       </a:r>
                     </a:p>
                   </a:txBody>
@@ -11978,7 +12002,7 @@
                         </a:defRPr>
                       </a:pPr>
                       <a:r>
-                        <a:t>+16.5 dB</a:t>
+                        <a:t>+16.9 dB</a:t>
                       </a:r>
                     </a:p>
                   </a:txBody>
@@ -12002,7 +12026,7 @@
                         </a:defRPr>
                       </a:pPr>
                       <a:r>
-                        <a:t>Tiết kiệm 45x công suất</a:t>
+                        <a:t>Tiết kiệm ~49x công suất</a:t>
                       </a:r>
                     </a:p>
                   </a:txBody>
@@ -12052,7 +12076,7 @@
                         </a:defRPr>
                       </a:pPr>
                       <a:r>
-                        <a:t>10.15 dB</a:t>
+                        <a:t>10.10 dB</a:t>
                       </a:r>
                     </a:p>
                   </a:txBody>
@@ -12076,7 +12100,7 @@
                         </a:defRPr>
                       </a:pPr>
                       <a:r>
-                        <a:t>10.15 dB</a:t>
+                        <a:t>10.10 dB</a:t>
                       </a:r>
                     </a:p>
                   </a:txBody>
@@ -12965,7 +12989,7 @@
               </a:defRPr>
             </a:pPr>
             <a:r>
-              <a:t>•  Kiểm chứng độc lập: Xây dựng đồng thời hai bộ mã nguồn kiểm chứng chéo trên MATLAB R2026 và Python 3.12 (NumPy/SciPy).</a:t>
+              <a:t>•  Kiểm chứng độc lập: Xây dựng đồng thời hai bộ mã nguồn kiểm chứng chéo trên MATLAB R2025b và Python 3.12 (NumPy/SciPy).</a:t>
             </a:r>
           </a:p>
         </p:txBody>
@@ -13072,7 +13096,7 @@
               </a:defRPr>
             </a:pPr>
             <a:r>
-              <a:t>MIMO 2x2 STBC tiết kiệm 16.5 dB công suất</a:t>
+              <a:t>MIMO 2x2 STBC tiết kiệm 16.9 dB công suất (49 lần)</a:t>
             </a:r>
           </a:p>
         </p:txBody>
@@ -13273,7 +13297,7 @@
               </a:defRPr>
             </a:pPr>
             <a:r>
-              <a:t>10.15 dB</a:t>
+              <a:t>10.10 dB</a:t>
             </a:r>
           </a:p>
           <a:p>
@@ -13837,7 +13861,7 @@
               </a:defRPr>
             </a:pPr>
             <a:r>
-              <a:t>•  Xây dựng thành công bộ mô phỏng Monte Carlo 2x10^5 bit trên cả hai nền tảng MATLAB và Python.</a:t>
+              <a:t>•  Xây dựng thành công bộ mô phỏng Monte Carlo 5x10^5 bit trên cả hai nền tảng MATLAB và Python.</a:t>
             </a:r>
           </a:p>
           <a:p>
@@ -13853,7 +13877,7 @@
               </a:defRPr>
             </a:pPr>
             <a:r>
-              <a:t>•  Kiểm chứng tính đúng đắn: Các đường cong mô phỏng BER và dung lượng Shannon trùng khớp hoàn hảo với các mô hình giải tích khép kín.</a:t>
+              <a:t>•  Kiểm chứng tính đúng đắn: Các đường cong mô phỏng BER và dung lượng Shannon khớp tốt với các mô hình giải tích khép kín.</a:t>
             </a:r>
           </a:p>
           <a:p>
@@ -13869,7 +13893,7 @@
               </a:defRPr>
             </a:pPr>
             <a:r>
-              <a:t>•  Xác thực độ lợi phân tập d=4 và độ lợi SNR +16.5 dB tại BER=10^-3 của hệ thống MIMO 2x2 Alamouti.</a:t>
+              <a:t>•  Xác thực độ lợi phân tập d=4 và độ lợi SNR +16.9 dB tại BER=10^-3 của hệ thống MIMO 2x2 Alamouti (tiết kiệm ~49 lần công suất).</a:t>
             </a:r>
           </a:p>
           <a:p>
@@ -13885,7 +13909,7 @@
               </a:defRPr>
             </a:pPr>
             <a:r>
-              <a:t>•  Khẳng định ngưỡng Water-filling 10.15 dB phân định rõ 2 chế độ Beamforming và Ghép kênh.</a:t>
+              <a:t>•  Khẳng định ngưỡng Water-filling 10.10 dB phân định rõ 2 chế độ Beamforming và Ghép kênh.</a:t>
             </a:r>
           </a:p>
         </p:txBody>
@@ -19171,7 +19195,7 @@
               </a:defRPr>
             </a:pPr>
             <a:r>
-              <a:t>•  Kênh trực giao song song: Chuyển đổi thành 2 kênh con độc lập tuyệt đối.</a:t>
+              <a:t>•  Triệt can nhiễu đa luồng: Chuyển đổi thành 2 kênh con song song không xuyên kênh.</a:t>
             </a:r>
           </a:p>
           <a:p>
@@ -19187,7 +19211,7 @@
               </a:defRPr>
             </a:pPr>
             <a:r>
-              <a:t>•  Ưu thế vượt trội: Hoàn toàn không gây khuếch đại tạp âm, song đòi hỏi cả CSIT và CSIR.</a:t>
+              <a:t>•  Đặc tính tạp âm: Giữ trắng tạp âm giữa các luồng, song khôi phục kênh con yếu (σ_2) vẫn bị khuếch đại nhiễu; Water-filling tối ưu phân bổ.</a:t>
             </a:r>
           </a:p>
         </p:txBody>

</xml_diff>